<commit_message>
Pestaña Reportes (costos, seguimiento, informes y analítica IA) y botón "Todas las opciones" en Gestión
Co-Authored-By: Claude Sonnet 5.5 <noreply@anthropic.com>
Claude-Session: https://claude.ai/code/session_01Hf3Bv2DfhJoQXrVqi8KboG
</commit_message>
<xml_diff>
--- a/docs/Accesos_por_perfil_LevantApp.pptx
+++ b/docs/Accesos_por_perfil_LevantApp.pptx
@@ -6733,7 +6733,7 @@
                           <a:ea typeface="Calibri" pitchFamily="34" charset="-122"/>
                           <a:cs typeface="Calibri" pitchFamily="34" charset="-120"/>
                         </a:rPr>
-                        <a:t>Seguimiento</a:t>
+                        <a:t>Reportes</a:t>
                       </a:r>
                       <a:endParaRPr lang="en-US" sz="1400" dirty="0">
                         <a:latin typeface="Calibri" charset="0"/>
@@ -8328,7 +8328,7 @@
                   <a:srgbClr val="1B2B2B"/>
                 </a:solidFill>
               </a:rPr>
-              <a:t>Entrar a Bodega, Gestión ni Seguimiento</a:t>
+              <a:t>Entrar a Bodega, Gestión ni Reportes</a:t>
             </a:r>
             <a:endParaRPr lang="en-US" sz="1500" dirty="0"/>
           </a:p>
@@ -9123,7 +9123,7 @@
                   <a:srgbClr val="1B2B2B"/>
                 </a:solidFill>
               </a:rPr>
-              <a:t>Entrar a Bodega, Gestión ni Seguimiento</a:t>
+              <a:t>Entrar a Bodega, Gestión ni Reportes</a:t>
             </a:r>
             <a:endParaRPr lang="en-US" sz="1500" dirty="0"/>
           </a:p>
@@ -9978,7 +9978,7 @@
                   <a:srgbClr val="1B2B2B"/>
                 </a:solidFill>
               </a:rPr>
-              <a:t>Entrar a Gestión ni Seguimiento</a:t>
+              <a:t>Entrar a Gestión ni Reportes</a:t>
             </a:r>
             <a:endParaRPr lang="en-US" sz="1500" dirty="0"/>
           </a:p>
@@ -10412,7 +10412,7 @@
                   <a:schemeClr val="tx1"/>
                 </a:solidFill>
               </a:rPr>
-              <a:t>Reportería, analítica con IA y seguimiento</a:t>
+              <a:t>Reportes: costos, seguimiento, informes y analítica con IA</a:t>
             </a:r>
             <a:endParaRPr lang="en-US" sz="1600" dirty="0"/>
           </a:p>

</xml_diff>